<commit_message>
chore(submission): refresh deck + screenshots from the code-built UI; add a business-model slide
- screenshots regenerated from the deterministic code-built compositions (crisp, consistent with the gifs/video) — replaces the old sparse screen recordings
- deck (now 12 slides): new Business model slide (pay-per-upload / persistence+privacy / monetize-your-data); three-pieces + why-it-fits updated to MCP + CLI + skill; storage slide refit to 16:9
</commit_message>
<xml_diff>
--- a/submission/WalDrive-deck.pptx
+++ b/submission/WalDrive-deck.pptx
@@ -16,9 +16,10 @@
     <p:sldId id="264" r:id="rId10"/>
     <p:sldId id="265" r:id="rId11"/>
     <p:sldId id="266" r:id="rId12"/>
+    <p:sldId id="267" r:id="rId13"/>
   </p:sldIdLst>
   <p:notesMasterIdLst>
-    <p:notesMasterId r:id="rId13"/>
+    <p:notesMasterId r:id="rId14"/>
   </p:notesMasterIdLst>
   <p:sldSz cx="12191695" cy="6858000"/>
   <p:notesSz cx="6858000" cy="12191695"/>
@@ -712,6 +713,94 @@
             <a:fld id="{F7021451-1387-4CA6-816F-3879F97B5CBC}" type="slidenum">
               <a:rPr lang="en-US"/>
               <a:t>11</a:t>
+            </a:fld>
+            <a:endParaRPr lang="en-US"/>
+          </a:p>
+        </p:txBody>
+      </p:sp>
+    </p:spTree>
+    <p:extLst>
+      <p:ext uri="{BB962C8B-B14F-4D97-AF65-F5344CB8AC3E}">
+        <p14:creationId xmlns:p14="http://schemas.microsoft.com/office/powerpoint/2010/main" val="1024086991"/>
+      </p:ext>
+    </p:extLst>
+  </p:cSld>
+  <p:clrMapOvr>
+    <a:masterClrMapping/>
+  </p:clrMapOvr>
+</p:notes>
+</file>
+
+<file path=ppt/notesSlides/notesSlide12.xml><?xml version="1.0" encoding="utf-8"?>
+<p:notes xmlns:a="http://schemas.openxmlformats.org/drawingml/2006/main" xmlns:r="http://schemas.openxmlformats.org/officeDocument/2006/relationships" xmlns:p="http://schemas.openxmlformats.org/presentationml/2006/main">
+  <p:cSld>
+    <p:spTree>
+      <p:nvGrpSpPr>
+        <p:cNvPr id="1" name=""/>
+        <p:cNvGrpSpPr/>
+        <p:nvPr/>
+      </p:nvGrpSpPr>
+      <p:grpSpPr>
+        <a:xfrm>
+          <a:off x="0" y="0"/>
+          <a:ext cx="0" cy="0"/>
+          <a:chOff x="0" y="0"/>
+          <a:chExt cx="0" cy="0"/>
+        </a:xfrm>
+      </p:grpSpPr>
+      <p:sp>
+        <p:nvSpPr>
+          <p:cNvPr id="2" name="Slide Image Placeholder 1"/>
+          <p:cNvSpPr>
+            <a:spLocks noGrp="1" noRot="1" noChangeAspect="1"/>
+          </p:cNvSpPr>
+          <p:nvPr>
+            <p:ph type="sldImg"/>
+          </p:nvPr>
+        </p:nvSpPr>
+        <p:spPr/>
+      </p:sp>
+      <p:sp>
+        <p:nvSpPr>
+          <p:cNvPr id="3" name="Notes Placeholder 2"/>
+          <p:cNvSpPr>
+            <a:spLocks noGrp="1"/>
+          </p:cNvSpPr>
+          <p:nvPr>
+            <p:ph type="body" idx="1"/>
+          </p:nvPr>
+        </p:nvSpPr>
+        <p:spPr/>
+        <p:txBody>
+          <a:bodyPr/>
+          <a:lstStyle/>
+          <a:p>
+            <a:r>
+              <a:rPr lang="en-US" dirty="0"/>
+              <a:t/>
+            </a:r>
+            <a:endParaRPr lang="en-US" dirty="0"/>
+          </a:p>
+        </p:txBody>
+      </p:sp>
+      <p:sp>
+        <p:nvSpPr>
+          <p:cNvPr id="4" name="Slide Number Placeholder 3"/>
+          <p:cNvSpPr>
+            <a:spLocks noGrp="1"/>
+          </p:cNvSpPr>
+          <p:nvPr>
+            <p:ph type="sldNum" sz="quarter" idx="10"/>
+          </p:nvPr>
+        </p:nvSpPr>
+        <p:spPr/>
+        <p:txBody>
+          <a:bodyPr/>
+          <a:lstStyle/>
+          <a:p>
+            <a:fld id="{F7021451-1387-4CA6-816F-3879F97B5CBC}" type="slidenum">
+              <a:rPr lang="en-US"/>
+              <a:t>12</a:t>
             </a:fld>
             <a:endParaRPr lang="en-US"/>
           </a:p>
@@ -2897,7 +2986,7 @@
                 <a:ea typeface="Inter" pitchFamily="34" charset="-122"/>
                 <a:cs typeface="Inter" pitchFamily="34" charset="-120"/>
               </a:rPr>
-              <a:t>The MCP server lets agents write artifacts and memory to the same data.</a:t>
+              <a:t>An MCP server, a waldrive CLI, and an installable skill let agents write to the same data.</a:t>
             </a:r>
             <a:endParaRPr lang="en-US" sz="1250" dirty="0"/>
           </a:p>
@@ -3078,7 +3167,7 @@
                 <a:ea typeface="JetBrains Mono" pitchFamily="34" charset="-122"/>
                 <a:cs typeface="JetBrains Mono" pitchFamily="34" charset="-120"/>
               </a:rPr>
-              <a:t>10 / 11</a:t>
+              <a:t>10 / 12</a:t>
             </a:r>
             <a:endParaRPr lang="en-US" sz="900" dirty="0"/>
           </a:p>
@@ -3155,6 +3244,713 @@
           <a:chExt cx="0" cy="0"/>
         </a:xfrm>
       </p:grpSpPr>
+      <p:sp>
+        <p:nvSpPr>
+          <p:cNvPr id="2" name="Text 0"/>
+          <p:cNvSpPr/>
+          <p:nvPr/>
+        </p:nvSpPr>
+        <p:spPr>
+          <a:xfrm>
+            <a:off x="640080" y="566928"/>
+            <a:ext cx="7315200" cy="274320"/>
+          </a:xfrm>
+          <a:prstGeom prst="rect">
+            <a:avLst/>
+          </a:prstGeom>
+          <a:noFill/>
+          <a:ln/>
+        </p:spPr>
+        <p:txBody>
+          <a:bodyPr wrap="square" lIns="0" tIns="0" rIns="0" bIns="0" rtlCol="0" anchor="ctr"/>
+          <a:lstStyle/>
+          <a:p>
+            <a:pPr algn="l" indent="0" marL="0">
+              <a:buNone/>
+            </a:pPr>
+            <a:r>
+              <a:rPr lang="en-US" sz="1200" b="1" spc="200" kern="0" dirty="0">
+                <a:solidFill>
+                  <a:srgbClr val="5E6AD2"/>
+                </a:solidFill>
+                <a:latin typeface="Inter" pitchFamily="34" charset="0"/>
+                <a:ea typeface="Inter" pitchFamily="34" charset="-122"/>
+                <a:cs typeface="Inter" pitchFamily="34" charset="-120"/>
+              </a:rPr>
+              <a:t>BUSINESS MODEL</a:t>
+            </a:r>
+            <a:endParaRPr lang="en-US" sz="1200" dirty="0"/>
+          </a:p>
+        </p:txBody>
+      </p:sp>
+      <p:sp>
+        <p:nvSpPr>
+          <p:cNvPr id="3" name="Text 1"/>
+          <p:cNvSpPr/>
+          <p:nvPr/>
+        </p:nvSpPr>
+        <p:spPr>
+          <a:xfrm>
+            <a:off x="640080" y="960120"/>
+            <a:ext cx="10972800" cy="640080"/>
+          </a:xfrm>
+          <a:prstGeom prst="rect">
+            <a:avLst/>
+          </a:prstGeom>
+          <a:noFill/>
+          <a:ln/>
+        </p:spPr>
+        <p:txBody>
+          <a:bodyPr wrap="square" lIns="0" tIns="0" rIns="0" bIns="0" rtlCol="0" anchor="ctr"/>
+          <a:lstStyle/>
+          <a:p>
+            <a:pPr indent="0" marL="0">
+              <a:buNone/>
+            </a:pPr>
+            <a:r>
+              <a:rPr lang="en-US" sz="3400" b="1" spc="-70" kern="0" dirty="0">
+                <a:solidFill>
+                  <a:srgbClr val="F7F8F8"/>
+                </a:solidFill>
+                <a:latin typeface="Inter" pitchFamily="34" charset="0"/>
+                <a:ea typeface="Inter" pitchFamily="34" charset="-122"/>
+                <a:cs typeface="Inter" pitchFamily="34" charset="-120"/>
+              </a:rPr>
+              <a:t>The drive that pays for itself</a:t>
+            </a:r>
+            <a:endParaRPr lang="en-US" sz="3400" dirty="0"/>
+          </a:p>
+        </p:txBody>
+      </p:sp>
+      <p:sp>
+        <p:nvSpPr>
+          <p:cNvPr id="4" name="Text 2"/>
+          <p:cNvSpPr/>
+          <p:nvPr/>
+        </p:nvSpPr>
+        <p:spPr>
+          <a:xfrm>
+            <a:off x="640080" y="1691640"/>
+            <a:ext cx="10789920" cy="457200"/>
+          </a:xfrm>
+          <a:prstGeom prst="rect">
+            <a:avLst/>
+          </a:prstGeom>
+          <a:noFill/>
+          <a:ln/>
+        </p:spPr>
+        <p:txBody>
+          <a:bodyPr wrap="square" lIns="0" tIns="0" rIns="0" bIns="0" rtlCol="0" anchor="ctr"/>
+          <a:lstStyle/>
+          <a:p>
+            <a:pPr indent="0" marL="0">
+              <a:buNone/>
+            </a:pPr>
+            <a:r>
+              <a:rPr lang="en-US" sz="1550" dirty="0">
+                <a:solidFill>
+                  <a:srgbClr val="8A8F98"/>
+                </a:solidFill>
+                <a:latin typeface="Inter" pitchFamily="34" charset="0"/>
+                <a:ea typeface="Inter" pitchFamily="34" charset="-122"/>
+                <a:cs typeface="Inter" pitchFamily="34" charset="-120"/>
+              </a:rPr>
+              <a:t>Agents are about to generate more data than humans ever have — and all of it needs a home that's owned, verifiable, and persistent. Free on testnet today.</a:t>
+            </a:r>
+            <a:endParaRPr lang="en-US" sz="1550" dirty="0"/>
+          </a:p>
+        </p:txBody>
+      </p:sp>
+      <p:sp>
+        <p:nvSpPr>
+          <p:cNvPr id="5" name="Shape 3"/>
+          <p:cNvSpPr/>
+          <p:nvPr/>
+        </p:nvSpPr>
+        <p:spPr>
+          <a:xfrm>
+            <a:off x="640080" y="2606040"/>
+            <a:ext cx="3362858" cy="3291840"/>
+          </a:xfrm>
+          <a:prstGeom prst="roundRect">
+            <a:avLst>
+              <a:gd name="adj" fmla="val 3333"/>
+            </a:avLst>
+          </a:prstGeom>
+          <a:solidFill>
+            <a:srgbClr val="0F1011"/>
+          </a:solidFill>
+          <a:ln w="12700">
+            <a:solidFill>
+              <a:srgbClr val="23252A"/>
+            </a:solidFill>
+            <a:prstDash val="solid"/>
+          </a:ln>
+        </p:spPr>
+      </p:sp>
+      <p:sp>
+        <p:nvSpPr>
+          <p:cNvPr id="6" name="Text 4"/>
+          <p:cNvSpPr/>
+          <p:nvPr/>
+        </p:nvSpPr>
+        <p:spPr>
+          <a:xfrm>
+            <a:off x="932688" y="2916936"/>
+            <a:ext cx="2814218" cy="274320"/>
+          </a:xfrm>
+          <a:prstGeom prst="rect">
+            <a:avLst/>
+          </a:prstGeom>
+          <a:noFill/>
+          <a:ln/>
+        </p:spPr>
+        <p:txBody>
+          <a:bodyPr wrap="square" lIns="0" tIns="0" rIns="0" bIns="0" rtlCol="0" anchor="ctr"/>
+          <a:lstStyle/>
+          <a:p>
+            <a:pPr indent="0" marL="0">
+              <a:buNone/>
+            </a:pPr>
+            <a:r>
+              <a:rPr lang="en-US" sz="1100" b="1" spc="150" kern="0" dirty="0">
+                <a:solidFill>
+                  <a:srgbClr val="5E6AD2"/>
+                </a:solidFill>
+                <a:latin typeface="Inter" pitchFamily="34" charset="0"/>
+                <a:ea typeface="Inter" pitchFamily="34" charset="-122"/>
+                <a:cs typeface="Inter" pitchFamily="34" charset="-120"/>
+              </a:rPr>
+              <a:t>METERED</a:t>
+            </a:r>
+            <a:endParaRPr lang="en-US" sz="1100" dirty="0"/>
+          </a:p>
+        </p:txBody>
+      </p:sp>
+      <p:sp>
+        <p:nvSpPr>
+          <p:cNvPr id="7" name="Text 5"/>
+          <p:cNvSpPr/>
+          <p:nvPr/>
+        </p:nvSpPr>
+        <p:spPr>
+          <a:xfrm>
+            <a:off x="932688" y="3282696"/>
+            <a:ext cx="2814218" cy="457200"/>
+          </a:xfrm>
+          <a:prstGeom prst="rect">
+            <a:avLst/>
+          </a:prstGeom>
+          <a:noFill/>
+          <a:ln/>
+        </p:spPr>
+        <p:txBody>
+          <a:bodyPr wrap="square" lIns="0" tIns="0" rIns="0" bIns="0" rtlCol="0" anchor="ctr"/>
+          <a:lstStyle/>
+          <a:p>
+            <a:pPr indent="0" marL="0">
+              <a:buNone/>
+            </a:pPr>
+            <a:r>
+              <a:rPr lang="en-US" sz="2000" b="1" dirty="0">
+                <a:solidFill>
+                  <a:srgbClr val="F7F8F8"/>
+                </a:solidFill>
+                <a:latin typeface="Inter" pitchFamily="34" charset="0"/>
+                <a:ea typeface="Inter" pitchFamily="34" charset="-122"/>
+                <a:cs typeface="Inter" pitchFamily="34" charset="-120"/>
+              </a:rPr>
+              <a:t>Pay per upload</a:t>
+            </a:r>
+            <a:endParaRPr lang="en-US" sz="2000" dirty="0"/>
+          </a:p>
+        </p:txBody>
+      </p:sp>
+      <p:sp>
+        <p:nvSpPr>
+          <p:cNvPr id="8" name="Text 6"/>
+          <p:cNvSpPr/>
+          <p:nvPr/>
+        </p:nvSpPr>
+        <p:spPr>
+          <a:xfrm>
+            <a:off x="932688" y="3886200"/>
+            <a:ext cx="2795930" cy="1828800"/>
+          </a:xfrm>
+          <a:prstGeom prst="rect">
+            <a:avLst/>
+          </a:prstGeom>
+          <a:noFill/>
+          <a:ln/>
+        </p:spPr>
+        <p:txBody>
+          <a:bodyPr wrap="square" lIns="0" tIns="0" rIns="0" bIns="0" rtlCol="0" anchor="t"/>
+          <a:lstStyle/>
+          <a:p>
+            <a:pPr indent="0" marL="0">
+              <a:lnSpc>
+                <a:spcPct val="132000"/>
+              </a:lnSpc>
+              <a:buNone/>
+            </a:pPr>
+            <a:r>
+              <a:rPr lang="en-US" sz="1300" dirty="0">
+                <a:solidFill>
+                  <a:srgbClr val="8A8F98"/>
+                </a:solidFill>
+                <a:latin typeface="Inter" pitchFamily="34" charset="0"/>
+                <a:ea typeface="Inter" pitchFamily="34" charset="-122"/>
+                <a:cs typeface="Inter" pitchFamily="34" charset="-120"/>
+              </a:rPr>
+              <a:t>On mainnet each write costs WAL storage + SUI gas, on a public ledger. WalDrive fronts the publisher; the FileRecord is the receipt — meter or bill an agent by reading its files.</a:t>
+            </a:r>
+            <a:endParaRPr lang="en-US" sz="1300" dirty="0"/>
+          </a:p>
+        </p:txBody>
+      </p:sp>
+      <p:sp>
+        <p:nvSpPr>
+          <p:cNvPr id="9" name="Shape 7"/>
+          <p:cNvSpPr/>
+          <p:nvPr/>
+        </p:nvSpPr>
+        <p:spPr>
+          <a:xfrm>
+            <a:off x="4414418" y="2606040"/>
+            <a:ext cx="3362858" cy="3291840"/>
+          </a:xfrm>
+          <a:prstGeom prst="roundRect">
+            <a:avLst>
+              <a:gd name="adj" fmla="val 3333"/>
+            </a:avLst>
+          </a:prstGeom>
+          <a:solidFill>
+            <a:srgbClr val="0F1011"/>
+          </a:solidFill>
+          <a:ln w="12700">
+            <a:solidFill>
+              <a:srgbClr val="23252A"/>
+            </a:solidFill>
+            <a:prstDash val="solid"/>
+          </a:ln>
+        </p:spPr>
+      </p:sp>
+      <p:sp>
+        <p:nvSpPr>
+          <p:cNvPr id="10" name="Text 8"/>
+          <p:cNvSpPr/>
+          <p:nvPr/>
+        </p:nvSpPr>
+        <p:spPr>
+          <a:xfrm>
+            <a:off x="4707026" y="2916936"/>
+            <a:ext cx="2814218" cy="274320"/>
+          </a:xfrm>
+          <a:prstGeom prst="rect">
+            <a:avLst/>
+          </a:prstGeom>
+          <a:noFill/>
+          <a:ln/>
+        </p:spPr>
+        <p:txBody>
+          <a:bodyPr wrap="square" lIns="0" tIns="0" rIns="0" bIns="0" rtlCol="0" anchor="ctr"/>
+          <a:lstStyle/>
+          <a:p>
+            <a:pPr indent="0" marL="0">
+              <a:buNone/>
+            </a:pPr>
+            <a:r>
+              <a:rPr lang="en-US" sz="1100" b="1" spc="150" kern="0" dirty="0">
+                <a:solidFill>
+                  <a:srgbClr val="5E6AD2"/>
+                </a:solidFill>
+                <a:latin typeface="Inter" pitchFamily="34" charset="0"/>
+                <a:ea typeface="Inter" pitchFamily="34" charset="-122"/>
+                <a:cs typeface="Inter" pitchFamily="34" charset="-120"/>
+              </a:rPr>
+              <a:t>SUBSCRIPTION</a:t>
+            </a:r>
+            <a:endParaRPr lang="en-US" sz="1100" dirty="0"/>
+          </a:p>
+        </p:txBody>
+      </p:sp>
+      <p:sp>
+        <p:nvSpPr>
+          <p:cNvPr id="11" name="Text 9"/>
+          <p:cNvSpPr/>
+          <p:nvPr/>
+        </p:nvSpPr>
+        <p:spPr>
+          <a:xfrm>
+            <a:off x="4707026" y="3282696"/>
+            <a:ext cx="2814218" cy="457200"/>
+          </a:xfrm>
+          <a:prstGeom prst="rect">
+            <a:avLst/>
+          </a:prstGeom>
+          <a:noFill/>
+          <a:ln/>
+        </p:spPr>
+        <p:txBody>
+          <a:bodyPr wrap="square" lIns="0" tIns="0" rIns="0" bIns="0" rtlCol="0" anchor="ctr"/>
+          <a:lstStyle/>
+          <a:p>
+            <a:pPr indent="0" marL="0">
+              <a:buNone/>
+            </a:pPr>
+            <a:r>
+              <a:rPr lang="en-US" sz="2000" b="1" dirty="0">
+                <a:solidFill>
+                  <a:srgbClr val="F7F8F8"/>
+                </a:solidFill>
+                <a:latin typeface="Inter" pitchFamily="34" charset="0"/>
+                <a:ea typeface="Inter" pitchFamily="34" charset="-122"/>
+                <a:cs typeface="Inter" pitchFamily="34" charset="-120"/>
+              </a:rPr>
+              <a:t>Persistence &amp; privacy</a:t>
+            </a:r>
+            <a:endParaRPr lang="en-US" sz="2000" dirty="0"/>
+          </a:p>
+        </p:txBody>
+      </p:sp>
+      <p:sp>
+        <p:nvSpPr>
+          <p:cNvPr id="12" name="Text 10"/>
+          <p:cNvSpPr/>
+          <p:nvPr/>
+        </p:nvSpPr>
+        <p:spPr>
+          <a:xfrm>
+            <a:off x="4707026" y="3886200"/>
+            <a:ext cx="2795930" cy="1828800"/>
+          </a:xfrm>
+          <a:prstGeom prst="rect">
+            <a:avLst/>
+          </a:prstGeom>
+          <a:noFill/>
+          <a:ln/>
+        </p:spPr>
+        <p:txBody>
+          <a:bodyPr wrap="square" lIns="0" tIns="0" rIns="0" bIns="0" rtlCol="0" anchor="t"/>
+          <a:lstStyle/>
+          <a:p>
+            <a:pPr indent="0" marL="0">
+              <a:lnSpc>
+                <a:spcPct val="132000"/>
+              </a:lnSpc>
+              <a:buNone/>
+            </a:pPr>
+            <a:r>
+              <a:rPr lang="en-US" sz="1300" dirty="0">
+                <a:solidFill>
+                  <a:srgbClr val="8A8F98"/>
+                </a:solidFill>
+                <a:latin typeface="Inter" pitchFamily="34" charset="0"/>
+                <a:ea typeface="Inter" pitchFamily="34" charset="-122"/>
+                <a:cs typeface="Inter" pitchFamily="34" charset="-120"/>
+              </a:rPr>
+              <a:t>Agent data must outlive the run. A paid tier auto-renews Walrus blobs before they expire, and unlocks private, encrypted (Seal) storage for sensitive data.</a:t>
+            </a:r>
+            <a:endParaRPr lang="en-US" sz="1300" dirty="0"/>
+          </a:p>
+        </p:txBody>
+      </p:sp>
+      <p:sp>
+        <p:nvSpPr>
+          <p:cNvPr id="13" name="Shape 11"/>
+          <p:cNvSpPr/>
+          <p:nvPr/>
+        </p:nvSpPr>
+        <p:spPr>
+          <a:xfrm>
+            <a:off x="8188757" y="2606040"/>
+            <a:ext cx="3362858" cy="3291840"/>
+          </a:xfrm>
+          <a:prstGeom prst="roundRect">
+            <a:avLst>
+              <a:gd name="adj" fmla="val 3333"/>
+            </a:avLst>
+          </a:prstGeom>
+          <a:solidFill>
+            <a:srgbClr val="0F1011"/>
+          </a:solidFill>
+          <a:ln w="12700">
+            <a:solidFill>
+              <a:srgbClr val="23252A"/>
+            </a:solidFill>
+            <a:prstDash val="solid"/>
+          </a:ln>
+        </p:spPr>
+      </p:sp>
+      <p:sp>
+        <p:nvSpPr>
+          <p:cNvPr id="14" name="Text 12"/>
+          <p:cNvSpPr/>
+          <p:nvPr/>
+        </p:nvSpPr>
+        <p:spPr>
+          <a:xfrm>
+            <a:off x="8481365" y="2916936"/>
+            <a:ext cx="2814218" cy="274320"/>
+          </a:xfrm>
+          <a:prstGeom prst="rect">
+            <a:avLst/>
+          </a:prstGeom>
+          <a:noFill/>
+          <a:ln/>
+        </p:spPr>
+        <p:txBody>
+          <a:bodyPr wrap="square" lIns="0" tIns="0" rIns="0" bIns="0" rtlCol="0" anchor="ctr"/>
+          <a:lstStyle/>
+          <a:p>
+            <a:pPr indent="0" marL="0">
+              <a:buNone/>
+            </a:pPr>
+            <a:r>
+              <a:rPr lang="en-US" sz="1100" b="1" spc="150" kern="0" dirty="0">
+                <a:solidFill>
+                  <a:srgbClr val="5E6AD2"/>
+                </a:solidFill>
+                <a:latin typeface="Inter" pitchFamily="34" charset="0"/>
+                <a:ea typeface="Inter" pitchFamily="34" charset="-122"/>
+                <a:cs typeface="Inter" pitchFamily="34" charset="-120"/>
+              </a:rPr>
+              <a:t>MARKETPLACE</a:t>
+            </a:r>
+            <a:endParaRPr lang="en-US" sz="1100" dirty="0"/>
+          </a:p>
+        </p:txBody>
+      </p:sp>
+      <p:sp>
+        <p:nvSpPr>
+          <p:cNvPr id="15" name="Text 13"/>
+          <p:cNvSpPr/>
+          <p:nvPr/>
+        </p:nvSpPr>
+        <p:spPr>
+          <a:xfrm>
+            <a:off x="8481365" y="3282696"/>
+            <a:ext cx="2814218" cy="457200"/>
+          </a:xfrm>
+          <a:prstGeom prst="rect">
+            <a:avLst/>
+          </a:prstGeom>
+          <a:noFill/>
+          <a:ln/>
+        </p:spPr>
+        <p:txBody>
+          <a:bodyPr wrap="square" lIns="0" tIns="0" rIns="0" bIns="0" rtlCol="0" anchor="ctr"/>
+          <a:lstStyle/>
+          <a:p>
+            <a:pPr indent="0" marL="0">
+              <a:buNone/>
+            </a:pPr>
+            <a:r>
+              <a:rPr lang="en-US" sz="2000" b="1" dirty="0">
+                <a:solidFill>
+                  <a:srgbClr val="F7F8F8"/>
+                </a:solidFill>
+                <a:latin typeface="Inter" pitchFamily="34" charset="0"/>
+                <a:ea typeface="Inter" pitchFamily="34" charset="-122"/>
+                <a:cs typeface="Inter" pitchFamily="34" charset="-120"/>
+              </a:rPr>
+              <a:t>Monetize your data</a:t>
+            </a:r>
+            <a:endParaRPr lang="en-US" sz="2000" dirty="0"/>
+          </a:p>
+        </p:txBody>
+      </p:sp>
+      <p:sp>
+        <p:nvSpPr>
+          <p:cNvPr id="16" name="Text 14"/>
+          <p:cNvSpPr/>
+          <p:nvPr/>
+        </p:nvSpPr>
+        <p:spPr>
+          <a:xfrm>
+            <a:off x="8481365" y="3886200"/>
+            <a:ext cx="2795930" cy="1828800"/>
+          </a:xfrm>
+          <a:prstGeom prst="rect">
+            <a:avLst/>
+          </a:prstGeom>
+          <a:noFill/>
+          <a:ln/>
+        </p:spPr>
+        <p:txBody>
+          <a:bodyPr wrap="square" lIns="0" tIns="0" rIns="0" bIns="0" rtlCol="0" anchor="t"/>
+          <a:lstStyle/>
+          <a:p>
+            <a:pPr indent="0" marL="0">
+              <a:lnSpc>
+                <a:spcPct val="132000"/>
+              </a:lnSpc>
+              <a:buNone/>
+            </a:pPr>
+            <a:r>
+              <a:rPr lang="en-US" sz="1300" dirty="0">
+                <a:solidFill>
+                  <a:srgbClr val="8A8F98"/>
+                </a:solidFill>
+                <a:latin typeface="Inter" pitchFamily="34" charset="0"/>
+                <a:ea typeface="Inter" pitchFamily="34" charset="-122"/>
+                <a:cs typeface="Inter" pitchFamily="34" charset="-120"/>
+              </a:rPr>
+              <a:t>A share-link paywall: other agents and humans pay on-chain to read your dataset or artifact, and WalDrive takes a small cut. Agent output becomes an asset, not a cost.</a:t>
+            </a:r>
+            <a:endParaRPr lang="en-US" sz="1300" dirty="0"/>
+          </a:p>
+        </p:txBody>
+      </p:sp>
+      <p:sp>
+        <p:nvSpPr>
+          <p:cNvPr id="17" name="Text 15"/>
+          <p:cNvSpPr/>
+          <p:nvPr/>
+        </p:nvSpPr>
+        <p:spPr>
+          <a:xfrm>
+            <a:off x="640080" y="6126480"/>
+            <a:ext cx="10972800" cy="365760"/>
+          </a:xfrm>
+          <a:prstGeom prst="rect">
+            <a:avLst/>
+          </a:prstGeom>
+          <a:noFill/>
+          <a:ln/>
+        </p:spPr>
+        <p:txBody>
+          <a:bodyPr wrap="square" lIns="0" tIns="0" rIns="0" bIns="0" rtlCol="0" anchor="ctr"/>
+          <a:lstStyle/>
+          <a:p>
+            <a:pPr indent="0" marL="0">
+              <a:buNone/>
+            </a:pPr>
+            <a:r>
+              <a:rPr lang="en-US" sz="1050" dirty="0">
+                <a:solidFill>
+                  <a:srgbClr val="62666D"/>
+                </a:solidFill>
+                <a:latin typeface="JetBrains Mono" pitchFamily="34" charset="0"/>
+                <a:ea typeface="JetBrains Mono" pitchFamily="34" charset="-122"/>
+                <a:cs typeface="JetBrains Mono" pitchFamily="34" charset="-120"/>
+              </a:rPr>
+              <a:t>Free on testnet today  ·  the model lands on mainnet</a:t>
+            </a:r>
+            <a:endParaRPr lang="en-US" sz="1050" dirty="0"/>
+          </a:p>
+        </p:txBody>
+      </p:sp>
+      <p:sp>
+        <p:nvSpPr>
+          <p:cNvPr id="18" name="Text 16"/>
+          <p:cNvSpPr/>
+          <p:nvPr/>
+        </p:nvSpPr>
+        <p:spPr>
+          <a:xfrm>
+            <a:off x="10637215" y="6400800"/>
+            <a:ext cx="1097280" cy="274320"/>
+          </a:xfrm>
+          <a:prstGeom prst="rect">
+            <a:avLst/>
+          </a:prstGeom>
+          <a:noFill/>
+          <a:ln/>
+        </p:spPr>
+        <p:txBody>
+          <a:bodyPr wrap="square" lIns="0" tIns="0" rIns="0" bIns="0" rtlCol="0" anchor="ctr"/>
+          <a:lstStyle/>
+          <a:p>
+            <a:pPr algn="r" indent="0" marL="0">
+              <a:buNone/>
+            </a:pPr>
+            <a:r>
+              <a:rPr lang="en-US" sz="900" dirty="0">
+                <a:solidFill>
+                  <a:srgbClr val="62666D"/>
+                </a:solidFill>
+                <a:latin typeface="JetBrains Mono" pitchFamily="34" charset="0"/>
+                <a:ea typeface="JetBrains Mono" pitchFamily="34" charset="-122"/>
+                <a:cs typeface="JetBrains Mono" pitchFamily="34" charset="-120"/>
+              </a:rPr>
+              <a:t>11 / 12</a:t>
+            </a:r>
+            <a:endParaRPr lang="en-US" sz="900" dirty="0"/>
+          </a:p>
+        </p:txBody>
+      </p:sp>
+      <p:sp>
+        <p:nvSpPr>
+          <p:cNvPr id="19" name="Text 17"/>
+          <p:cNvSpPr/>
+          <p:nvPr/>
+        </p:nvSpPr>
+        <p:spPr>
+          <a:xfrm>
+            <a:off x="640080" y="6400800"/>
+            <a:ext cx="2743200" cy="274320"/>
+          </a:xfrm>
+          <a:prstGeom prst="rect">
+            <a:avLst/>
+          </a:prstGeom>
+          <a:noFill/>
+          <a:ln/>
+        </p:spPr>
+        <p:txBody>
+          <a:bodyPr wrap="square" lIns="0" tIns="0" rIns="0" bIns="0" rtlCol="0" anchor="ctr"/>
+          <a:lstStyle/>
+          <a:p>
+            <a:pPr algn="l" indent="0" marL="0">
+              <a:buNone/>
+            </a:pPr>
+            <a:r>
+              <a:rPr lang="en-US" sz="900" dirty="0">
+                <a:solidFill>
+                  <a:srgbClr val="62666D"/>
+                </a:solidFill>
+                <a:latin typeface="Inter" pitchFamily="34" charset="0"/>
+                <a:ea typeface="Inter" pitchFamily="34" charset="-122"/>
+                <a:cs typeface="Inter" pitchFamily="34" charset="-120"/>
+              </a:rPr>
+              <a:t>WalDrive</a:t>
+            </a:r>
+            <a:endParaRPr lang="en-US" sz="900" dirty="0"/>
+          </a:p>
+        </p:txBody>
+      </p:sp>
+    </p:spTree>
+  </p:cSld>
+  <p:clrMapOvr>
+    <a:masterClrMapping/>
+  </p:clrMapOvr>
+</p:sld>
+</file>
+
+<file path=ppt/slides/slide12.xml><?xml version="1.0" encoding="utf-8"?>
+<p:sld xmlns:a="http://schemas.openxmlformats.org/drawingml/2006/main" xmlns:r="http://schemas.openxmlformats.org/officeDocument/2006/relationships" xmlns:p="http://schemas.openxmlformats.org/presentationml/2006/main">
+  <p:cSld name="Slide 12">
+    <p:bg>
+      <p:bgPr>
+        <a:solidFill>
+          <a:srgbClr val="010102"/>
+        </a:solidFill>
+      </p:bgPr>
+    </p:bg>
+    <p:spTree>
+      <p:nvGrpSpPr>
+        <p:cNvPr id="1" name=""/>
+        <p:cNvGrpSpPr/>
+        <p:nvPr/>
+      </p:nvGrpSpPr>
+      <p:grpSpPr>
+        <a:xfrm>
+          <a:off x="0" y="0"/>
+          <a:ext cx="0" cy="0"/>
+          <a:chOff x="0" y="0"/>
+          <a:chExt cx="0" cy="0"/>
+        </a:xfrm>
+      </p:grpSpPr>
       <p:pic>
         <p:nvPicPr>
           <p:cNvPr id="2" name="Image 0" descr="/Users/mac/WorkSpace/Web3_Project/WalDrive/public/landing/icon-512.png">    </p:cNvPr>
@@ -4619,7 +5415,7 @@
                 <a:ea typeface="JetBrains Mono" pitchFamily="34" charset="-122"/>
                 <a:cs typeface="JetBrains Mono" pitchFamily="34" charset="-120"/>
               </a:rPr>
-              <a:t>02 / 11</a:t>
+              <a:t>02 / 12</a:t>
             </a:r>
             <a:endParaRPr lang="en-US" sz="900" dirty="0"/>
           </a:p>
@@ -5480,7 +6276,7 @@
                 <a:ea typeface="JetBrains Mono" pitchFamily="34" charset="-122"/>
                 <a:cs typeface="JetBrains Mono" pitchFamily="34" charset="-120"/>
               </a:rPr>
-              <a:t>03 / 11</a:t>
+              <a:t>03 / 12</a:t>
             </a:r>
             <a:endParaRPr lang="en-US" sz="900" dirty="0"/>
           </a:p>
@@ -6132,7 +6928,7 @@
                 <a:ea typeface="JetBrains Mono" pitchFamily="34" charset="-122"/>
                 <a:cs typeface="JetBrains Mono" pitchFamily="34" charset="-120"/>
               </a:rPr>
-              <a:t>04 / 11</a:t>
+              <a:t>04 / 12</a:t>
             </a:r>
             <a:endParaRPr lang="en-US" sz="900" dirty="0"/>
           </a:p>
@@ -6701,7 +7497,7 @@
                 <a:ea typeface="JetBrains Mono" pitchFamily="34" charset="-122"/>
                 <a:cs typeface="JetBrains Mono" pitchFamily="34" charset="-120"/>
               </a:rPr>
-              <a:t>05 / 11</a:t>
+              <a:t>05 / 12</a:t>
             </a:r>
             <a:endParaRPr lang="en-US" sz="900" dirty="0"/>
           </a:p>
@@ -7270,7 +8066,7 @@
                 <a:ea typeface="JetBrains Mono" pitchFamily="34" charset="-122"/>
                 <a:cs typeface="JetBrains Mono" pitchFamily="34" charset="-120"/>
               </a:rPr>
-              <a:t>06 / 11</a:t>
+              <a:t>06 / 12</a:t>
             </a:r>
             <a:endParaRPr lang="en-US" sz="900" dirty="0"/>
           </a:p>
@@ -7518,7 +8314,7 @@
         <p:spPr>
           <a:xfrm>
             <a:off x="640080" y="2514600"/>
-            <a:ext cx="6903720" cy="3379207"/>
+            <a:ext cx="6400800" cy="3600450"/>
           </a:xfrm>
           <a:prstGeom prst="rect">
             <a:avLst/>
@@ -7541,11 +8337,11 @@
         <p:spPr>
           <a:xfrm>
             <a:off x="640080" y="2514600"/>
-            <a:ext cx="6903720" cy="3379207"/>
+            <a:ext cx="6400800" cy="3600450"/>
           </a:xfrm>
           <a:prstGeom prst="roundRect">
             <a:avLst>
-              <a:gd name="adj" fmla="val 2706"/>
+              <a:gd name="adj" fmla="val 2540"/>
             </a:avLst>
           </a:prstGeom>
           <a:solidFill>
@@ -7569,12 +8365,12 @@
         </p:nvSpPr>
         <p:spPr>
           <a:xfrm>
-            <a:off x="8001000" y="2514600"/>
-            <a:ext cx="3550615" cy="1024128"/>
+            <a:off x="7498080" y="2514600"/>
+            <a:ext cx="4053535" cy="1097280"/>
           </a:xfrm>
           <a:prstGeom prst="roundRect">
             <a:avLst>
-              <a:gd name="adj" fmla="val 10714"/>
+              <a:gd name="adj" fmla="val 10000"/>
             </a:avLst>
           </a:prstGeom>
           <a:solidFill>
@@ -7596,8 +8392,8 @@
         </p:nvSpPr>
         <p:spPr>
           <a:xfrm>
-            <a:off x="8238744" y="2697480"/>
-            <a:ext cx="3129991" cy="365760"/>
+            <a:off x="7735824" y="2697480"/>
+            <a:ext cx="3632911" cy="365760"/>
           </a:xfrm>
           <a:prstGeom prst="rect">
             <a:avLst/>
@@ -7635,8 +8431,8 @@
         </p:nvSpPr>
         <p:spPr>
           <a:xfrm>
-            <a:off x="8238744" y="3044952"/>
-            <a:ext cx="3129991" cy="438912"/>
+            <a:off x="7735824" y="3044952"/>
+            <a:ext cx="3632911" cy="438912"/>
           </a:xfrm>
           <a:prstGeom prst="rect">
             <a:avLst/>
@@ -7677,12 +8473,12 @@
         </p:nvSpPr>
         <p:spPr>
           <a:xfrm>
-            <a:off x="8001000" y="3694176"/>
-            <a:ext cx="3550615" cy="1024128"/>
+            <a:off x="7498080" y="3776472"/>
+            <a:ext cx="4053535" cy="1097280"/>
           </a:xfrm>
           <a:prstGeom prst="roundRect">
             <a:avLst>
-              <a:gd name="adj" fmla="val 10714"/>
+              <a:gd name="adj" fmla="val 10000"/>
             </a:avLst>
           </a:prstGeom>
           <a:solidFill>
@@ -7704,8 +8500,8 @@
         </p:nvSpPr>
         <p:spPr>
           <a:xfrm>
-            <a:off x="8238744" y="3877056"/>
-            <a:ext cx="3129991" cy="365760"/>
+            <a:off x="7735824" y="3959352"/>
+            <a:ext cx="3632911" cy="365760"/>
           </a:xfrm>
           <a:prstGeom prst="rect">
             <a:avLst/>
@@ -7743,8 +8539,8 @@
         </p:nvSpPr>
         <p:spPr>
           <a:xfrm>
-            <a:off x="8238744" y="4224528"/>
-            <a:ext cx="3129991" cy="438912"/>
+            <a:off x="7735824" y="4306824"/>
+            <a:ext cx="3632911" cy="438912"/>
           </a:xfrm>
           <a:prstGeom prst="rect">
             <a:avLst/>
@@ -7785,12 +8581,12 @@
         </p:nvSpPr>
         <p:spPr>
           <a:xfrm>
-            <a:off x="8001000" y="4873752"/>
-            <a:ext cx="3550615" cy="1024128"/>
+            <a:off x="7498080" y="5038344"/>
+            <a:ext cx="4053535" cy="1097280"/>
           </a:xfrm>
           <a:prstGeom prst="roundRect">
             <a:avLst>
-              <a:gd name="adj" fmla="val 10714"/>
+              <a:gd name="adj" fmla="val 10000"/>
             </a:avLst>
           </a:prstGeom>
           <a:solidFill>
@@ -7812,8 +8608,8 @@
         </p:nvSpPr>
         <p:spPr>
           <a:xfrm>
-            <a:off x="8238744" y="5056632"/>
-            <a:ext cx="3129991" cy="365760"/>
+            <a:off x="7735824" y="5221224"/>
+            <a:ext cx="3632911" cy="365760"/>
           </a:xfrm>
           <a:prstGeom prst="rect">
             <a:avLst/>
@@ -7851,8 +8647,8 @@
         </p:nvSpPr>
         <p:spPr>
           <a:xfrm>
-            <a:off x="8238744" y="5404104"/>
-            <a:ext cx="3129991" cy="438912"/>
+            <a:off x="7735824" y="5568696"/>
+            <a:ext cx="3632911" cy="438912"/>
           </a:xfrm>
           <a:prstGeom prst="rect">
             <a:avLst/>
@@ -7918,7 +8714,7 @@
                 <a:ea typeface="JetBrains Mono" pitchFamily="34" charset="-122"/>
                 <a:cs typeface="JetBrains Mono" pitchFamily="34" charset="-120"/>
               </a:rPr>
-              <a:t>07 / 11</a:t>
+              <a:t>07 / 12</a:t>
             </a:r>
             <a:endParaRPr lang="en-US" sz="900" dirty="0"/>
           </a:p>
@@ -8427,7 +9223,7 @@
                 <a:ea typeface="Inter" pitchFamily="34" charset="-122"/>
                 <a:cs typeface="Inter" pitchFamily="34" charset="-120"/>
               </a:rPr>
-              <a:t>MCP server</a:t>
+              <a:t>MCP · CLI · skill</a:t>
             </a:r>
             <a:endParaRPr lang="en-US" sz="2100" dirty="0"/>
           </a:p>
@@ -8469,7 +9265,7 @@
                 <a:ea typeface="Inter" pitchFamily="34" charset="-122"/>
                 <a:cs typeface="Inter" pitchFamily="34" charset="-120"/>
               </a:rPr>
-              <a:t>AI clients and scripts operate the same Walrus data from the command line.</a:t>
+              <a:t>Agents write the same Walrus data three ways — an MCP server, a waldrive CLI, and an installable skill.</a:t>
             </a:r>
             <a:endParaRPr lang="en-US" sz="1300" dirty="0"/>
           </a:p>
@@ -8556,7 +9352,7 @@
                 <a:ea typeface="JetBrains Mono" pitchFamily="34" charset="-122"/>
                 <a:cs typeface="JetBrains Mono" pitchFamily="34" charset="-120"/>
               </a:rPr>
-              <a:t>list_files</a:t>
+              <a:t>waldrive upload</a:t>
             </a:r>
             <a:endParaRPr lang="en-US" sz="1250" dirty="0"/>
           </a:p>
@@ -8577,28 +9373,7 @@
                 <a:ea typeface="JetBrains Mono" pitchFamily="34" charset="-122"/>
                 <a:cs typeface="JetBrains Mono" pitchFamily="34" charset="-120"/>
               </a:rPr>
-              <a:t>download_file</a:t>
-            </a:r>
-            <a:endParaRPr lang="en-US" sz="1250" dirty="0"/>
-          </a:p>
-          <a:p>
-            <a:pPr marL="177800" indent="-177800">
-              <a:spcAft>
-                <a:spcPts val="600"/>
-              </a:spcAft>
-              <a:buSzPct val="100000"/>
-              <a:buChar char="•"/>
-            </a:pPr>
-            <a:r>
-              <a:rPr lang="en-US" sz="1250" dirty="0">
-                <a:solidFill>
-                  <a:srgbClr val="D0D6E0"/>
-                </a:solidFill>
-                <a:latin typeface="JetBrains Mono" pitchFamily="34" charset="0"/>
-                <a:ea typeface="JetBrains Mono" pitchFamily="34" charset="-122"/>
-                <a:cs typeface="JetBrains Mono" pitchFamily="34" charset="-120"/>
-              </a:rPr>
-              <a:t>get_file_info</a:t>
+              <a:t>npx skills add</a:t>
             </a:r>
             <a:endParaRPr lang="en-US" sz="1250" dirty="0"/>
           </a:p>
@@ -8892,7 +9667,7 @@
                 <a:ea typeface="JetBrains Mono" pitchFamily="34" charset="-122"/>
                 <a:cs typeface="JetBrains Mono" pitchFamily="34" charset="-120"/>
               </a:rPr>
-              <a:t>08 / 11</a:t>
+              <a:t>08 / 12</a:t>
             </a:r>
             <a:endParaRPr lang="en-US" sz="900" dirty="0"/>
           </a:p>
@@ -10008,7 +10783,7 @@
                 <a:ea typeface="JetBrains Mono" pitchFamily="34" charset="-122"/>
                 <a:cs typeface="JetBrains Mono" pitchFamily="34" charset="-120"/>
               </a:rPr>
-              <a:t>09 / 11</a:t>
+              <a:t>09 / 12</a:t>
             </a:r>
             <a:endParaRPr lang="en-US" sz="900" dirty="0"/>
           </a:p>

</xml_diff>

<commit_message>
docs: position WalDrive as the human interface layer for agent data
- README: everyone else ships a protocol or SDK; WalDrive is the screen you
  operate agent data from, every feature live on testnet
- landing Hero: add the live-on-testnet, no-mock, no-login-wall line
- landing ValueProps: tighten the agent write-path card to the positioning
  ("the protocols are the plumbing; this is the screen you operate them from")
- deck: human-interface-layer subline on the title slide
</commit_message>
<xml_diff>
--- a/submission/WalDrive-deck.pptx
+++ b/submission/WalDrive-deck.pptx
@@ -1992,7 +1992,7 @@
         <p:spPr>
           <a:xfrm>
             <a:off x="640080" y="3886200"/>
-            <a:ext cx="10058400" cy="640080"/>
+            <a:ext cx="10058400" cy="548640"/>
           </a:xfrm>
           <a:prstGeom prst="rect">
             <a:avLst/>
@@ -2024,7 +2024,46 @@
       </p:sp>
       <p:sp>
         <p:nvSpPr>
-          <p:cNvPr id="7" name="Shape 4"/>
+          <p:cNvPr id="7" name="Text 4"/>
+          <p:cNvSpPr/>
+          <p:nvPr/>
+        </p:nvSpPr>
+        <p:spPr>
+          <a:xfrm>
+            <a:off x="640080" y="4480560"/>
+            <a:ext cx="10515600" cy="347472"/>
+          </a:xfrm>
+          <a:prstGeom prst="rect">
+            <a:avLst/>
+          </a:prstGeom>
+          <a:noFill/>
+          <a:ln/>
+        </p:spPr>
+        <p:txBody>
+          <a:bodyPr wrap="square" lIns="0" tIns="0" rIns="0" bIns="0" rtlCol="0" anchor="ctr"/>
+          <a:lstStyle/>
+          <a:p>
+            <a:pPr algn="l" indent="0" marL="0">
+              <a:buNone/>
+            </a:pPr>
+            <a:r>
+              <a:rPr lang="en-US" sz="1400" dirty="0">
+                <a:solidFill>
+                  <a:srgbClr val="8A8F98"/>
+                </a:solidFill>
+                <a:latin typeface="Inter" pitchFamily="34" charset="0"/>
+                <a:ea typeface="Inter" pitchFamily="34" charset="-122"/>
+                <a:cs typeface="Inter" pitchFamily="34" charset="-120"/>
+              </a:rPr>
+              <a:t>The human interface layer for agent data — the screen you operate it from. Live on testnet, no mock.</a:t>
+            </a:r>
+            <a:endParaRPr lang="en-US" sz="1400" dirty="0"/>
+          </a:p>
+        </p:txBody>
+      </p:sp>
+      <p:sp>
+        <p:nvSpPr>
+          <p:cNvPr id="8" name="Shape 5"/>
           <p:cNvSpPr/>
           <p:nvPr/>
         </p:nvSpPr>
@@ -2051,7 +2090,7 @@
       </p:sp>
       <p:sp>
         <p:nvSpPr>
-          <p:cNvPr id="8" name="Text 5"/>
+          <p:cNvPr id="9" name="Text 6"/>
           <p:cNvSpPr/>
           <p:nvPr/>
         </p:nvSpPr>
@@ -2090,7 +2129,7 @@
       </p:sp>
       <p:sp>
         <p:nvSpPr>
-          <p:cNvPr id="9" name="Shape 6"/>
+          <p:cNvPr id="10" name="Shape 7"/>
           <p:cNvSpPr/>
           <p:nvPr/>
         </p:nvSpPr>
@@ -2117,7 +2156,7 @@
       </p:sp>
       <p:sp>
         <p:nvSpPr>
-          <p:cNvPr id="10" name="Text 7"/>
+          <p:cNvPr id="11" name="Text 8"/>
           <p:cNvSpPr/>
           <p:nvPr/>
         </p:nvSpPr>
@@ -2156,7 +2195,7 @@
       </p:sp>
       <p:sp>
         <p:nvSpPr>
-          <p:cNvPr id="11" name="Shape 8"/>
+          <p:cNvPr id="12" name="Shape 9"/>
           <p:cNvSpPr/>
           <p:nvPr/>
         </p:nvSpPr>
@@ -2183,7 +2222,7 @@
       </p:sp>
       <p:sp>
         <p:nvSpPr>
-          <p:cNvPr id="12" name="Text 9"/>
+          <p:cNvPr id="13" name="Text 10"/>
           <p:cNvSpPr/>
           <p:nvPr/>
         </p:nvSpPr>
@@ -2222,7 +2261,7 @@
       </p:sp>
       <p:sp>
         <p:nvSpPr>
-          <p:cNvPr id="13" name="Shape 10"/>
+          <p:cNvPr id="14" name="Shape 11"/>
           <p:cNvSpPr/>
           <p:nvPr/>
         </p:nvSpPr>
@@ -2249,7 +2288,7 @@
       </p:sp>
       <p:sp>
         <p:nvSpPr>
-          <p:cNvPr id="14" name="Text 11"/>
+          <p:cNvPr id="15" name="Text 12"/>
           <p:cNvSpPr/>
           <p:nvPr/>
         </p:nvSpPr>
@@ -2288,7 +2327,7 @@
       </p:sp>
       <p:sp>
         <p:nvSpPr>
-          <p:cNvPr id="15" name="Text 12"/>
+          <p:cNvPr id="16" name="Text 13"/>
           <p:cNvSpPr/>
           <p:nvPr/>
         </p:nvSpPr>

</xml_diff>

<commit_message>
docs: surface encryption, renewal, and provenance across README / landing / deck
- README desktop-console bullet: Seal encryption (owner-only), one-click storage
  renewal before expiry, content-addressed version timeline
- landing: "Yours, and encrypted" value prop — Seal owner-only + renew before expiry
- deck title: add the "Encrypted · Seal" capability token
</commit_message>
<xml_diff>
--- a/submission/WalDrive-deck.pptx
+++ b/submission/WalDrive-deck.pptx
@@ -2268,7 +2268,7 @@
         <p:spPr>
           <a:xfrm>
             <a:off x="7871155" y="4937760"/>
-            <a:ext cx="1152144" cy="384048"/>
+            <a:ext cx="1656893" cy="384048"/>
           </a:xfrm>
           <a:prstGeom prst="roundRect">
             <a:avLst>
@@ -2295,8 +2295,74 @@
         <p:spPr>
           <a:xfrm>
             <a:off x="7871155" y="4937760"/>
+            <a:ext cx="1656893" cy="384048"/>
+          </a:xfrm>
+          <a:prstGeom prst="rect">
+            <a:avLst/>
+          </a:prstGeom>
+          <a:noFill/>
+          <a:ln/>
+        </p:spPr>
+        <p:txBody>
+          <a:bodyPr wrap="square" lIns="0" tIns="0" rIns="0" bIns="0" rtlCol="0" anchor="ctr"/>
+          <a:lstStyle/>
+          <a:p>
+            <a:pPr algn="ctr" indent="0" marL="0">
+              <a:buNone/>
+            </a:pPr>
+            <a:r>
+              <a:rPr lang="en-US" sz="1150" dirty="0">
+                <a:solidFill>
+                  <a:srgbClr val="8A8F98"/>
+                </a:solidFill>
+                <a:latin typeface="Inter" pitchFamily="34" charset="0"/>
+                <a:ea typeface="Inter" pitchFamily="34" charset="-122"/>
+                <a:cs typeface="Inter" pitchFamily="34" charset="-120"/>
+              </a:rPr>
+              <a:t>Encrypted · Seal</a:t>
+            </a:r>
+            <a:endParaRPr lang="en-US" sz="1150" dirty="0"/>
+          </a:p>
+        </p:txBody>
+      </p:sp>
+      <p:sp>
+        <p:nvSpPr>
+          <p:cNvPr id="16" name="Shape 13"/>
+          <p:cNvSpPr/>
+          <p:nvPr/>
+        </p:nvSpPr>
+        <p:spPr>
+          <a:xfrm>
+            <a:off x="9692640" y="4937760"/>
             <a:ext cx="1152144" cy="384048"/>
           </a:xfrm>
+          <a:prstGeom prst="roundRect">
+            <a:avLst>
+              <a:gd name="adj" fmla="val 50000"/>
+            </a:avLst>
+          </a:prstGeom>
+          <a:solidFill>
+            <a:srgbClr val="0F1011"/>
+          </a:solidFill>
+          <a:ln w="12700">
+            <a:solidFill>
+              <a:srgbClr val="23252A"/>
+            </a:solidFill>
+            <a:prstDash val="solid"/>
+          </a:ln>
+        </p:spPr>
+      </p:sp>
+      <p:sp>
+        <p:nvSpPr>
+          <p:cNvPr id="17" name="Text 14"/>
+          <p:cNvSpPr/>
+          <p:nvPr/>
+        </p:nvSpPr>
+        <p:spPr>
+          <a:xfrm>
+            <a:off x="9692640" y="4937760"/>
+            <a:ext cx="1152144" cy="384048"/>
+          </a:xfrm>
           <a:prstGeom prst="rect">
             <a:avLst/>
           </a:prstGeom>
@@ -2327,7 +2393,7 @@
       </p:sp>
       <p:sp>
         <p:nvSpPr>
-          <p:cNvPr id="16" name="Text 13"/>
+          <p:cNvPr id="18" name="Text 15"/>
           <p:cNvSpPr/>
           <p:nvPr/>
         </p:nvSpPr>

</xml_diff>

<commit_message>
docs: untrack internal competitive-research note; rebuild deck with renamed stills
</commit_message>
<xml_diff>
--- a/submission/WalDrive-deck.pptx
+++ b/submission/WalDrive-deck.pptx
@@ -7712,7 +7712,7 @@
                 <a:ea typeface="Inter" pitchFamily="34" charset="-122"/>
                 <a:cs typeface="Inter" pitchFamily="34" charset="-120"/>
               </a:rPr>
-              <a:t>VERSION HISTORY · ROLLBACK</a:t>
+              <a:t>PROVENANCE · ROLLBACK</a:t>
             </a:r>
             <a:endParaRPr lang="en-US" sz="1200" dirty="0"/>
           </a:p>
@@ -7796,7 +7796,7 @@
                 <a:ea typeface="Inter" pitchFamily="34" charset="-122"/>
                 <a:cs typeface="Inter" pitchFamily="34" charset="-120"/>
               </a:rPr>
-              <a:t>Each version is its own FileRecord, linked by parent_version_id. Roll back to any revision in one transaction — no re-upload.</a:t>
+              <a:t>Each version is its own FileRecord, linked by parent_version_id and content-addressed — so a restore that re-points at an old blob is provably identical. Roll back in one transaction, no re-upload.</a:t>
             </a:r>
             <a:endParaRPr lang="en-US" sz="1550" dirty="0"/>
           </a:p>
@@ -7937,7 +7937,7 @@
                 <a:ea typeface="Inter" pitchFamily="34" charset="-122"/>
                 <a:cs typeface="Inter" pitchFamily="34" charset="-120"/>
               </a:rPr>
-              <a:t>One-tx rollback</a:t>
+              <a:t>Content-addressed</a:t>
             </a:r>
             <a:pPr indent="0" marL="0">
               <a:lnSpc>
@@ -7954,7 +7954,7 @@
                 <a:ea typeface="Inter" pitchFamily="34" charset="-122"/>
                 <a:cs typeface="Inter" pitchFamily="34" charset="-120"/>
               </a:rPr>
-              <a:t>  restore any revision</a:t>
+              <a:t>  identical bytes provable</a:t>
             </a:r>
             <a:endParaRPr lang="en-US" sz="1350" dirty="0"/>
           </a:p>
@@ -8016,7 +8016,7 @@
                 <a:ea typeface="Inter" pitchFamily="34" charset="-122"/>
                 <a:cs typeface="Inter" pitchFamily="34" charset="-120"/>
               </a:rPr>
-              <a:t>Exactly idea #032</a:t>
+              <a:t>One-tx rollback</a:t>
             </a:r>
             <a:pPr indent="0" marL="0">
               <a:lnSpc>
@@ -8033,7 +8033,7 @@
                 <a:ea typeface="Inter" pitchFamily="34" charset="-122"/>
                 <a:cs typeface="Inter" pitchFamily="34" charset="-120"/>
               </a:rPr>
-              <a:t>  history + rollback</a:t>
+              <a:t>  restore any revision</a:t>
             </a:r>
             <a:endParaRPr lang="en-US" sz="1350" dirty="0"/>
           </a:p>
@@ -8080,7 +8080,7 @@
       </p:sp>
       <p:pic>
         <p:nvPicPr>
-          <p:cNvPr id="12" name="Image 0" descr="/Users/mac/WorkSpace/Web3_Project/WalDrive/submission/_build/assets/versions.png">    </p:cNvPr>
+          <p:cNvPr id="12" name="Image 0" descr="/Users/mac/WorkSpace/Web3_Project/WalDrive/submission/_build/assets/provenance.png">    </p:cNvPr>
           <p:cNvPicPr>
             <a:picLocks noChangeAspect="1"/>
           </p:cNvPicPr>
@@ -8281,7 +8281,7 @@
                 <a:ea typeface="Inter" pitchFamily="34" charset="-122"/>
                 <a:cs typeface="Inter" pitchFamily="34" charset="-120"/>
               </a:rPr>
-              <a:t>OWNERSHIP</a:t>
+              <a:t>ENCRYPTION · OWNERSHIP</a:t>
             </a:r>
             <a:endParaRPr lang="en-US" sz="1200" dirty="0"/>
           </a:p>
@@ -8320,7 +8320,7 @@
                 <a:ea typeface="Inter" pitchFamily="34" charset="-122"/>
                 <a:cs typeface="Inter" pitchFamily="34" charset="-120"/>
               </a:rPr>
-              <a:t>You own your storage</a:t>
+              <a:t>Sealed to your wallet</a:t>
             </a:r>
             <a:endParaRPr lang="en-US" sz="3300" dirty="0"/>
           </a:p>
@@ -8362,7 +8362,7 @@
                 <a:ea typeface="Inter" pitchFamily="34" charset="-122"/>
                 <a:cs typeface="Inter" pitchFamily="34" charset="-120"/>
               </a:rPr>
-              <a:t>The Walrus Blob object lands in your wallet via </a:t>
+              <a:t>Turn on </a:t>
             </a:r>
             <a:pPr indent="0" marL="0">
               <a:lnSpc>
@@ -8379,7 +8379,7 @@
                 <a:ea typeface="JetBrains Mono" pitchFamily="34" charset="-122"/>
                 <a:cs typeface="JetBrains Mono" pitchFamily="34" charset="-120"/>
               </a:rPr>
-              <a:t>send_object_to</a:t>
+              <a:t>Seal</a:t>
             </a:r>
             <a:pPr indent="0" marL="0">
               <a:lnSpc>
@@ -8396,7 +8396,7 @@
                 <a:ea typeface="Inter" pitchFamily="34" charset="-122"/>
                 <a:cs typeface="Inter" pitchFamily="34" charset="-120"/>
               </a:rPr>
-              <a:t>. Extend it before expiry, or delete to reclaim. Gas comes one click from the built-in faucet.</a:t>
+              <a:t> and the bytes on Walrus are ciphertext only your wallet can unseal. The Blob object lands in your wallet too — renew it before expiry, or delete to reclaim.</a:t>
             </a:r>
             <a:endParaRPr lang="en-US" sz="1600" dirty="0"/>
           </a:p>
@@ -8404,7 +8404,7 @@
       </p:sp>
       <p:pic>
         <p:nvPicPr>
-          <p:cNvPr id="5" name="Image 0" descr="/Users/mac/WorkSpace/Web3_Project/WalDrive/submission/_build/assets/storage.png">    </p:cNvPr>
+          <p:cNvPr id="5" name="Image 0" descr="/Users/mac/WorkSpace/Web3_Project/WalDrive/submission/_build/assets/encrypt.png">    </p:cNvPr>
           <p:cNvPicPr>
             <a:picLocks noChangeAspect="1"/>
           </p:cNvPicPr>

</xml_diff>